<commit_message>
Make the repository English-only
Translate all documentation into English and move the Chinese originals
and Chinese-only planning notes out of the repository (kept locally by the
author). Frozen records (labeling prompts, the annotators' codebook, the
factual-calibration review sample, labeling run and time logs) stay
unchanged with English translations next to them.

Translate Chinese output strings in the collection and export scripts;
reconcile.py reproduces the English excel_reconciliation.md byte for byte
and build_ai_package.py still reproduces the v1 prompt hash. Analysis
docstrings were translated and script_sha256.csv refreshed; no results
changed. Speaker notes and SCRIPT.md now hold the English script only.
</commit_message>
<xml_diff>
--- a/presentation/Unexplained_Pessimism_slides.pptx
+++ b/presentation/Unexplained_Pessimism_slides.pptx
@@ -519,17 +519,6 @@
               <a:t>Hi, I’m Jonas. Americans feel much worse about the economy than the numbers suggest. Is the news to blame? Our answer: mostly no.</a:t>
             </a:r>
           </a:p>
-          <a:p/>
-          <a:p>
-            <a:r>
-              <a:t>—— 中文对照 ——</a:t>
-            </a:r>
-          </a:p>
-          <a:p>
-            <a:r>
-              <a:t>大家好，我是 Jonas。美国人对经济的感受比数据显示的差得多。这要怪新闻吗？我们的答案是：基本不是。</a:t>
-            </a:r>
-          </a:p>
         </p:txBody>
       </p:sp>
       <p:sp>
@@ -606,17 +595,6 @@
               <a:t>First, the gap. We predict the Michigan index from unemployment, inflation and GDP growth, using only data known at the time. [CLICK] Blue is the prediction. [CLICK] Black is what people say. [CLICK] The gap is about 36 points in 2025 and 40 in 2026. The economy explains only about a tenth of the drop since 2019.</a:t>
             </a:r>
           </a:p>
-          <a:p/>
-          <a:p>
-            <a:r>
-              <a:t>—— 中文对照 ——</a:t>
-            </a:r>
-          </a:p>
-          <a:p>
-            <a:r>
-              <a:t>先看缺口。我们用失业率、通胀和 GDP 增长来预测密歇根消费者信心指数，而且只用当时已知的数据。[点击] 蓝线是预测值。[点击] 黑线是人们实际的回答。[点击] 缺口在 2025 年约 36 点，2026 年约 40 点。2019 年以来的下降，经济数据只能解释大约十分之一。</a:t>
-            </a:r>
-          </a:p>
         </p:txBody>
       </p:sp>
       <p:sp>
@@ -693,17 +671,6 @@
               <a:t>Three explanations are possible: real pressures the headline numbers miss, like high prices; the media; or a problem with the survey or the model. [CLICK] We fixed all our tests in advance, including eight results that would count against the media story.</a:t>
             </a:r>
           </a:p>
-          <a:p/>
-          <a:p>
-            <a:r>
-              <a:t>—— 中文对照 ——</a:t>
-            </a:r>
-          </a:p>
-          <a:p>
-            <a:r>
-              <a:t>可能的解释有三种：一是头条数据没有反映的真实压力，比如物价太高；二是媒体；三是调查或模型本身的问题。[点击] 所有检验都是事先定好的，其中包括八条一旦出现就不利于媒体解释的结果。</a:t>
-            </a:r>
-          </a:p>
         </p:txBody>
       </p:sp>
       <p:sp>
@@ -780,17 +747,6 @@
               <a:t>Start with measurement. The gap is similar in every income, age, region and education group. [CLICK] The survey moved online in 2024, but the gap kept growing after that. [CLICK] Party mix moves it by less than 3 points. [CLICK] And it was this large before the campaign.</a:t>
             </a:r>
           </a:p>
-          <a:p/>
-          <a:p>
-            <a:r>
-              <a:t>—— 中文对照 ——</a:t>
-            </a:r>
-          </a:p>
-          <a:p>
-            <a:r>
-              <a:t>先看测量问题。各个收入、年龄、地区和学历组的缺口都差不多。[点击] 2024 年调查改成了线上，但之后缺口还在扩大。[点击] 党派构成的变化最多只带来不到 3 点。[点击] 而且竞选开始之前缺口就已经这么大了。</a:t>
-            </a:r>
-          </a:p>
         </p:txBody>
       </p:sp>
       <p:sp>
@@ -867,17 +823,6 @@
               <a:t>Now the media. We collected about 167,000 news items, posts and comments. An LLM coded over 11,000, and two people labeled 360 by hand to check it. [CLICK] On tone, the LLM agrees with humans almost as well as they agree with each other, and about twice as well as word lists. [CLICK] Swapping political names showed no sign of bias.</a:t>
             </a:r>
           </a:p>
-          <a:p/>
-          <a:p>
-            <a:r>
-              <a:t>—— 中文对照 ——</a:t>
-            </a:r>
-          </a:p>
-          <a:p>
-            <a:r>
-              <a:t>再看媒体。我们收集了约 16.7 万条新闻、帖子和评论，用大语言模型编码了其中一万一千多条，并请两个人独立手工标注了 360 条来检验。[点击] 在语气上，模型和人的一致程度几乎和两个人之间一样高，大约是词典法的两倍。[点击] 把政治人物的名字互换之后，也没有发现偏差。</a:t>
-            </a:r>
-          </a:p>
         </p:txBody>
       </p:sp>
       <p:sp>
@@ -954,17 +899,6 @@
               <a:t>Coverage treats good and bad news alike, and only 2 of 68 checkable numbers were wrong. [CLICK] What changed is blame: under Trump’s second term, 40 percent of items blame the White House. [CLICK] But tariffs are his own decisions, so blame is not proof of bias.</a:t>
             </a:r>
           </a:p>
-          <a:p/>
-          <a:p>
-            <a:r>
-              <a:t>—— 中文对照 ——</a:t>
-            </a:r>
-          </a:p>
-          <a:p>
-            <a:r>
-              <a:t>报道对好消息和坏消息的处理差不多，能核对的 68 个数字里只有 2 个是错的。[点击] 变化最大的是归咎：特朗普第二任期内，40% 的报道把问题归咎于白宫。[点击] 但关税本来就是总统自己的决定，所以归咎不能证明有偏差。</a:t>
-            </a:r>
-          </a:p>
         </p:txBody>
       </p:sp>
       <p:sp>
@@ -1041,17 +975,6 @@
               <a:t>The key test: does news tone help forecast sentiment? Each dot is one version of the test. [CLICK] Added to the economy model, tone helps a little. [CLICK] But with household costs and politics included, none of 20 versions is significant. [CLICK] At most, tone explains about 5 percent of the gap.</a:t>
             </a:r>
           </a:p>
-          <a:p/>
-          <a:p>
-            <a:r>
-              <a:t>—— 中文对照 ——</a:t>
-            </a:r>
-          </a:p>
-          <a:p>
-            <a:r>
-              <a:t>关键检验：新闻语气能不能帮助预测消费者信心？每个点是检验的一个版本。[点击] 只加在经济模型上时，语气有一点帮助。[点击] 但加入家庭成本和政治因素之后，20 个版本没有一个显著。[点击] 语气最多只能解释缺口的约 5%。</a:t>
-            </a:r>
-          </a:p>
         </p:txBody>
       </p:sp>
       <p:sp>
@@ -1128,17 +1051,6 @@
               <a:t>Back to our three explanations. [CLICK] Measurement is ruled out. [CLICK] The media story is weak: two of our eight tests go against it. [CLICK] Real pressures stay open: high prices may matter, but our data cannot size them. Next, an experiment could test cause.</a:t>
             </a:r>
           </a:p>
-          <a:p/>
-          <a:p>
-            <a:r>
-              <a:t>—— 中文对照 ——</a:t>
-            </a:r>
-          </a:p>
-          <a:p>
-            <a:r>
-              <a:t>回到三种解释。[点击] 测量问题被排除了。[点击] 媒体解释很弱：八条预设检验中有两条与它相反。[点击] 真实压力还没有定论：高物价可能有影响，但我们的数据无法量化。下一步可以用实验来检验因果。</a:t>
-            </a:r>
-          </a:p>
         </p:txBody>
       </p:sp>
       <p:sp>
@@ -1213,17 +1125,6 @@
           <a:p>
             <a:r>
               <a:t>What does this mean for finance? [CLICK] In 2026 the index averages about 51; the economy points to 91. [CLICK] That is below any reading before 2020, so old models would see a deep downturn. [CLICK] So treat the gap as lasting, not noise. Track it with its error band, next to prices and rates. News tone will not fix it. Thank you.</a:t>
-            </a:r>
-          </a:p>
-          <a:p/>
-          <a:p>
-            <a:r>
-              <a:t>—— 中文对照 ——</a:t>
-            </a:r>
-          </a:p>
-          <a:p>
-            <a:r>
-              <a:t>这对金融意味着什么？[点击] 2026 年这个指数平均约 51，经济数据指向 91。[点击] 这比 2020 年以前的任何读数都低，按旧规律建的模型会把它看成深度衰退。[点击] 所以要把缺口当成持续的状态，而不是噪音；连同误差带一起跟踪它，同时看物价和利率。新闻语气修正不了它。谢谢大家。</a:t>
             </a:r>
           </a:p>
         </p:txBody>

</xml_diff>